<commit_message>
Update analysis to Update 3/4: new scripts, figures, GSEA, and Claude memory
Add pipeline_update3.R, analysis_update4.R, build_slides.py, spatrack_bc_mac.py,
download scripts, updated figures_update_3 outputs (sanity checks, UMAP, DEG,
GSEA panels), updated presentation pptx, and Claude AI memory files for
project continuity. Exclude heavy Seurat objects (*.rds >500MB) and job *.err logs.

Co-Authored-By: Claude Sonnet 4.6 <noreply@anthropic.com>
</commit_message>
<xml_diff>
--- a/BM project-human data_update_3.pptx
+++ b/BM project-human data_update_3.pptx
@@ -22,6 +22,8 @@
     <p:sldId id="270" r:id="rId21"/>
     <p:sldId id="271" r:id="rId22"/>
     <p:sldId id="272" r:id="rId23"/>
+    <p:sldId id="273" r:id="rId24"/>
+    <p:sldId id="274" r:id="rId25"/>
   </p:sldIdLst>
   <p:sldSz cx="12188952" cy="6858000" type="screen4x3"/>
   <p:notesSz cx="6858000" cy="9144000"/>
@@ -3625,9 +3627,42 @@
           </a:p>
         </p:txBody>
       </p:sp>
+      <p:sp>
+        <p:nvSpPr>
+          <p:cNvPr id="4" name="TextBox 3"/>
+          <p:cNvSpPr txBox="1"/>
+          <p:nvPr/>
+        </p:nvSpPr>
+        <p:spPr>
+          <a:xfrm>
+            <a:off x="274320" y="621792"/>
+            <a:ext cx="10972800" cy="320040"/>
+          </a:xfrm>
+          <a:prstGeom prst="rect">
+            <a:avLst/>
+          </a:prstGeom>
+          <a:noFill/>
+        </p:spPr>
+        <p:txBody>
+          <a:bodyPr wrap="none">
+            <a:spAutoFit/>
+          </a:bodyPr>
+          <a:lstStyle/>
+          <a:p>
+            <a:r>
+              <a:rPr sz="1300">
+                <a:solidFill>
+                  <a:srgbClr val="CCDDEE"/>
+                </a:solidFill>
+              </a:rPr>
+              <a:t>HALLMARK (blue) · C6 (lt.blue) · GO:BP (green) · Reactome (orange) · C7-IMMUNESIGDB (purple)</a:t>
+            </a:r>
+          </a:p>
+        </p:txBody>
+      </p:sp>
       <p:pic>
         <p:nvPicPr>
-          <p:cNvPr id="4" name="Picture 3" descr="05e_gsea_alldb_stacking.png"/>
+          <p:cNvPr id="5" name="Picture 4" descr="05e_gsea_alldb_stacking.png"/>
           <p:cNvPicPr>
             <a:picLocks noChangeAspect="1"/>
           </p:cNvPicPr>
@@ -3858,7 +3893,7 @@
                   <a:srgbClr val="FFFFFF"/>
                 </a:solidFill>
               </a:rPr>
-              <a:t>GSEA (Broader) — Cluster 1 (BC_ER+)</a:t>
+              <a:t>GSEA (Broader) — Cluster 1 (BC_ER+) by Hypothesis</a:t>
             </a:r>
           </a:p>
         </p:txBody>
@@ -3977,14 +4012,14 @@
                   <a:srgbClr val="FFFFFF"/>
                 </a:solidFill>
               </a:rPr>
-              <a:t>Bone Site / Tissue Origin per Macrophage Sub-cluster</a:t>
+              <a:t>GSEA — Cluster 1 Hypothesis Groups (Colored by Direction)</a:t>
             </a:r>
           </a:p>
         </p:txBody>
       </p:sp>
       <p:pic>
         <p:nvPicPr>
-          <p:cNvPr id="4" name="Picture 3" descr="07_tissue_origin_per_cluster.png"/>
+          <p:cNvPr id="4" name="Picture 3" descr="05c_cluster1_hypo_gsea.png"/>
           <p:cNvPicPr>
             <a:picLocks noChangeAspect="1"/>
           </p:cNvPicPr>
@@ -4096,14 +4131,14 @@
                   <a:srgbClr val="FFFFFF"/>
                 </a:solidFill>
               </a:rPr>
-              <a:t>Treatment Response per Macrophage Sub-cluster</a:t>
+              <a:t>Bone Site / Tissue Origin per Macrophage Sub-cluster</a:t>
             </a:r>
           </a:p>
         </p:txBody>
       </p:sp>
       <p:pic>
         <p:nvPicPr>
-          <p:cNvPr id="4" name="Picture 3" descr="08_treatment_per_cluster.png"/>
+          <p:cNvPr id="4" name="Picture 3" descr="07_tissue_origin_per_cluster.png"/>
           <p:cNvPicPr>
             <a:picLocks noChangeAspect="1"/>
           </p:cNvPicPr>
@@ -4215,6 +4250,244 @@
                   <a:srgbClr val="FFFFFF"/>
                 </a:solidFill>
               </a:rPr>
+              <a:t>Treatment Response per Macrophage Sub-cluster</a:t>
+            </a:r>
+          </a:p>
+        </p:txBody>
+      </p:sp>
+      <p:pic>
+        <p:nvPicPr>
+          <p:cNvPr id="4" name="Picture 3" descr="08_treatment_per_cluster.png"/>
+          <p:cNvPicPr>
+            <a:picLocks noChangeAspect="1"/>
+          </p:cNvPicPr>
+          <p:nvPr/>
+        </p:nvPicPr>
+        <p:blipFill>
+          <a:blip r:embed="rId2"/>
+          <a:stretch>
+            <a:fillRect/>
+          </a:stretch>
+        </p:blipFill>
+        <p:spPr>
+          <a:xfrm>
+            <a:off x="365760" y="1097280"/>
+            <a:ext cx="11430000" cy="5577840"/>
+          </a:xfrm>
+          <a:prstGeom prst="rect">
+            <a:avLst/>
+          </a:prstGeom>
+        </p:spPr>
+      </p:pic>
+    </p:spTree>
+  </p:cSld>
+  <p:clrMapOvr>
+    <a:masterClrMapping/>
+  </p:clrMapOvr>
+</p:sld>
+</file>
+
+<file path=ppt/slides/slide18.xml><?xml version="1.0" encoding="utf-8"?>
+<p:sld xmlns:a="http://schemas.openxmlformats.org/drawingml/2006/main" xmlns:p="http://schemas.openxmlformats.org/presentationml/2006/main" xmlns:r="http://schemas.openxmlformats.org/officeDocument/2006/relationships">
+  <p:cSld>
+    <p:spTree>
+      <p:nvGrpSpPr>
+        <p:cNvPr id="1" name=""/>
+        <p:cNvGrpSpPr/>
+        <p:nvPr/>
+      </p:nvGrpSpPr>
+      <p:grpSpPr/>
+      <p:sp>
+        <p:nvSpPr>
+          <p:cNvPr id="2" name="Rectangle 1"/>
+          <p:cNvSpPr/>
+          <p:nvPr/>
+        </p:nvSpPr>
+        <p:spPr>
+          <a:xfrm>
+            <a:off x="0" y="0"/>
+            <a:ext cx="12188952" cy="1005840"/>
+          </a:xfrm>
+          <a:prstGeom prst="rect">
+            <a:avLst/>
+          </a:prstGeom>
+          <a:solidFill>
+            <a:srgbClr val="1F497D"/>
+          </a:solidFill>
+          <a:ln>
+            <a:noFill/>
+          </a:ln>
+        </p:spPr>
+        <p:style>
+          <a:lnRef idx="1">
+            <a:schemeClr val="accent1"/>
+          </a:lnRef>
+          <a:fillRef idx="3">
+            <a:schemeClr val="accent1"/>
+          </a:fillRef>
+          <a:effectRef idx="2">
+            <a:schemeClr val="accent1"/>
+          </a:effectRef>
+          <a:fontRef idx="minor">
+            <a:schemeClr val="lt1"/>
+          </a:fontRef>
+        </p:style>
+        <p:txBody>
+          <a:bodyPr rtlCol="0" anchor="ctr"/>
+          <a:lstStyle/>
+          <a:p>
+            <a:pPr algn="ctr"/>
+          </a:p>
+        </p:txBody>
+      </p:sp>
+      <p:sp>
+        <p:nvSpPr>
+          <p:cNvPr id="3" name="TextBox 2"/>
+          <p:cNvSpPr txBox="1"/>
+          <p:nvPr/>
+        </p:nvSpPr>
+        <p:spPr>
+          <a:xfrm>
+            <a:off x="274320" y="109728"/>
+            <a:ext cx="10972800" cy="502920"/>
+          </a:xfrm>
+          <a:prstGeom prst="rect">
+            <a:avLst/>
+          </a:prstGeom>
+          <a:noFill/>
+        </p:spPr>
+        <p:txBody>
+          <a:bodyPr wrap="none">
+            <a:spAutoFit/>
+          </a:bodyPr>
+          <a:lstStyle/>
+          <a:p>
+            <a:pPr algn="l"/>
+            <a:r>
+              <a:rPr sz="2400" b="1">
+                <a:solidFill>
+                  <a:srgbClr val="FFFFFF"/>
+                </a:solidFill>
+              </a:rPr>
+              <a:t>Gender Distribution per Macrophage Sub-cluster</a:t>
+            </a:r>
+          </a:p>
+        </p:txBody>
+      </p:sp>
+      <p:pic>
+        <p:nvPicPr>
+          <p:cNvPr id="4" name="Picture 3" descr="06_gender_per_cluster.png"/>
+          <p:cNvPicPr>
+            <a:picLocks noChangeAspect="1"/>
+          </p:cNvPicPr>
+          <p:nvPr/>
+        </p:nvPicPr>
+        <p:blipFill>
+          <a:blip r:embed="rId2"/>
+          <a:stretch>
+            <a:fillRect/>
+          </a:stretch>
+        </p:blipFill>
+        <p:spPr>
+          <a:xfrm>
+            <a:off x="365760" y="1097280"/>
+            <a:ext cx="11430000" cy="5577840"/>
+          </a:xfrm>
+          <a:prstGeom prst="rect">
+            <a:avLst/>
+          </a:prstGeom>
+        </p:spPr>
+      </p:pic>
+    </p:spTree>
+  </p:cSld>
+  <p:clrMapOvr>
+    <a:masterClrMapping/>
+  </p:clrMapOvr>
+</p:sld>
+</file>
+
+<file path=ppt/slides/slide19.xml><?xml version="1.0" encoding="utf-8"?>
+<p:sld xmlns:a="http://schemas.openxmlformats.org/drawingml/2006/main" xmlns:p="http://schemas.openxmlformats.org/presentationml/2006/main" xmlns:r="http://schemas.openxmlformats.org/officeDocument/2006/relationships">
+  <p:cSld>
+    <p:spTree>
+      <p:nvGrpSpPr>
+        <p:cNvPr id="1" name=""/>
+        <p:cNvGrpSpPr/>
+        <p:nvPr/>
+      </p:nvGrpSpPr>
+      <p:grpSpPr/>
+      <p:sp>
+        <p:nvSpPr>
+          <p:cNvPr id="2" name="Rectangle 1"/>
+          <p:cNvSpPr/>
+          <p:nvPr/>
+        </p:nvSpPr>
+        <p:spPr>
+          <a:xfrm>
+            <a:off x="0" y="0"/>
+            <a:ext cx="12188952" cy="1005840"/>
+          </a:xfrm>
+          <a:prstGeom prst="rect">
+            <a:avLst/>
+          </a:prstGeom>
+          <a:solidFill>
+            <a:srgbClr val="1F497D"/>
+          </a:solidFill>
+          <a:ln>
+            <a:noFill/>
+          </a:ln>
+        </p:spPr>
+        <p:style>
+          <a:lnRef idx="1">
+            <a:schemeClr val="accent1"/>
+          </a:lnRef>
+          <a:fillRef idx="3">
+            <a:schemeClr val="accent1"/>
+          </a:fillRef>
+          <a:effectRef idx="2">
+            <a:schemeClr val="accent1"/>
+          </a:effectRef>
+          <a:fontRef idx="minor">
+            <a:schemeClr val="lt1"/>
+          </a:fontRef>
+        </p:style>
+        <p:txBody>
+          <a:bodyPr rtlCol="0" anchor="ctr"/>
+          <a:lstStyle/>
+          <a:p>
+            <a:pPr algn="ctr"/>
+          </a:p>
+        </p:txBody>
+      </p:sp>
+      <p:sp>
+        <p:nvSpPr>
+          <p:cNvPr id="3" name="TextBox 2"/>
+          <p:cNvSpPr txBox="1"/>
+          <p:nvPr/>
+        </p:nvSpPr>
+        <p:spPr>
+          <a:xfrm>
+            <a:off x="274320" y="109728"/>
+            <a:ext cx="10972800" cy="502920"/>
+          </a:xfrm>
+          <a:prstGeom prst="rect">
+            <a:avLst/>
+          </a:prstGeom>
+          <a:noFill/>
+        </p:spPr>
+        <p:txBody>
+          <a:bodyPr wrap="none">
+            <a:spAutoFit/>
+          </a:bodyPr>
+          <a:lstStyle/>
+          <a:p>
+            <a:pPr algn="l"/>
+            <a:r>
+              <a:rPr sz="2400" b="1">
+                <a:solidFill>
+                  <a:srgbClr val="FFFFFF"/>
+                </a:solidFill>
+              </a:rPr>
               <a:t>Summary — Update 3</a:t>
             </a:r>
           </a:p>
@@ -5215,9 +5488,42 @@
           </a:p>
         </p:txBody>
       </p:sp>
+      <p:sp>
+        <p:nvSpPr>
+          <p:cNvPr id="4" name="TextBox 3"/>
+          <p:cNvSpPr txBox="1"/>
+          <p:nvPr/>
+        </p:nvSpPr>
+        <p:spPr>
+          <a:xfrm>
+            <a:off x="274320" y="621792"/>
+            <a:ext cx="10972800" cy="320040"/>
+          </a:xfrm>
+          <a:prstGeom prst="rect">
+            <a:avLst/>
+          </a:prstGeom>
+          <a:noFill/>
+        </p:spPr>
+        <p:txBody>
+          <a:bodyPr wrap="none">
+            <a:spAutoFit/>
+          </a:bodyPr>
+          <a:lstStyle/>
+          <a:p>
+            <a:r>
+              <a:rPr sz="1300">
+                <a:solidFill>
+                  <a:srgbClr val="CCDDEE"/>
+                </a:solidFill>
+              </a:rPr>
+              <a:t>n.neighbors=10  min.dist=0.05  resolution=0.3  n_clusters=11</a:t>
+            </a:r>
+          </a:p>
+        </p:txBody>
+      </p:sp>
       <p:pic>
         <p:nvPicPr>
-          <p:cNvPr id="4" name="Picture 3" descr="01_umap_overview.png"/>
+          <p:cNvPr id="5" name="Picture 4" descr="01_umap_overview.png"/>
           <p:cNvPicPr>
             <a:picLocks noChangeAspect="1"/>
           </p:cNvPicPr>

</xml_diff>